<commit_message>
Presentation: integration resultats transfer learning (98%)
- slide transfer learning: matrice de confusion VGG16 + bandeau 57% -> 98%
- slide conclusion: 98% au lieu de "suite logique"
- script oral: narration slide 14/15 reecrite, Q/R jury mises a jour (ImageNet, overfitting)

Co-Authored-By: Claude Opus 4.8 <noreply@anthropic.com>
</commit_message>
<xml_diff>
--- a/presentation/presentation.pptx
+++ b/presentation/presentation.pptx
@@ -5673,7 +5673,7 @@
                 </a:solidFill>
                 <a:latin typeface="Calibri"/>
               </a:rPr>
-              <a:t>La suite : transfer learning</a:t>
+              <a:t>Transfer learning : on fait sauter le plafond</a:t>
             </a:r>
           </a:p>
         </p:txBody>
@@ -5800,8 +5800,8 @@
         </p:nvSpPr>
         <p:spPr>
           <a:xfrm>
-            <a:off x="548640" y="1554480"/>
-            <a:ext cx="6583680" cy="3657600"/>
+            <a:off x="548640" y="1417320"/>
+            <a:ext cx="5486400" cy="2926080"/>
           </a:xfrm>
           <a:prstGeom prst="rect">
             <a:avLst/>
@@ -5816,11 +5816,11 @@
           <a:p>
             <a:pPr>
               <a:spcAft>
-                <a:spcPts val="1400"/>
+                <a:spcPts val="1200"/>
               </a:spcAft>
             </a:pPr>
             <a:r>
-              <a:rPr sz="1800" b="1">
+              <a:rPr sz="1600" b="1">
                 <a:solidFill>
                   <a:srgbClr val="3F8A5B"/>
                 </a:solidFill>
@@ -5829,24 +5829,24 @@
               <a:t>›  </a:t>
             </a:r>
             <a:r>
-              <a:rPr sz="1800">
+              <a:rPr sz="1600">
                 <a:solidFill>
                   <a:srgbClr val="3C3C3C"/>
                 </a:solidFill>
                 <a:latin typeface="Calibri"/>
               </a:rPr>
-              <a:t>Réseau pré-entraîné sur des millions
-d'images (VGG16, Xception)</a:t>
+              <a:t>VGG16 pré-entraîné sur des millions
+d'images, couches gelées</a:t>
             </a:r>
           </a:p>
           <a:p>
             <a:pPr>
               <a:spcAft>
-                <a:spcPts val="1400"/>
+                <a:spcPts val="1200"/>
               </a:spcAft>
             </a:pPr>
             <a:r>
-              <a:rPr sz="1800" b="1">
+              <a:rPr sz="1600" b="1">
                 <a:solidFill>
                   <a:srgbClr val="3F8A5B"/>
                 </a:solidFill>
@@ -5855,24 +5855,24 @@
               <a:t>›  </a:t>
             </a:r>
             <a:r>
-              <a:rPr sz="1800">
+              <a:rPr sz="1600">
                 <a:solidFill>
                   <a:srgbClr val="3C3C3C"/>
                 </a:solidFill>
                 <a:latin typeface="Calibri"/>
               </a:rPr>
-              <a:t>Il calcule les caractéristiques
-à la place de PCA / HOG</a:t>
+              <a:t>Il remplace PCA / HOG pour calculer
+les caractéristiques</a:t>
             </a:r>
           </a:p>
           <a:p>
             <a:pPr>
               <a:spcAft>
-                <a:spcPts val="1400"/>
+                <a:spcPts val="1200"/>
               </a:spcAft>
             </a:pPr>
             <a:r>
-              <a:rPr sz="1800" b="1">
+              <a:rPr sz="1600" b="1">
                 <a:solidFill>
                   <a:srgbClr val="3F8A5B"/>
                 </a:solidFill>
@@ -5881,65 +5881,14 @@
               <a:t>›  </a:t>
             </a:r>
             <a:r>
-              <a:rPr sz="1800">
+              <a:rPr sz="1600">
                 <a:solidFill>
                   <a:srgbClr val="3C3C3C"/>
                 </a:solidFill>
                 <a:latin typeface="Calibri"/>
               </a:rPr>
-              <a:t>On gèle les couches, on ajoute une
-petite tête entraînée sur nos 6 races</a:t>
-            </a:r>
-          </a:p>
-          <a:p>
-            <a:pPr>
-              <a:spcAft>
-                <a:spcPts val="1400"/>
-              </a:spcAft>
-            </a:pPr>
-            <a:r>
-              <a:rPr sz="1800" b="1">
-                <a:solidFill>
-                  <a:srgbClr val="3F8A5B"/>
-                </a:solidFill>
-                <a:latin typeface="Calibri"/>
-              </a:rPr>
-              <a:t>›  </a:t>
-            </a:r>
-            <a:r>
-              <a:rPr sz="1800">
-                <a:solidFill>
-                  <a:srgbClr val="3C3C3C"/>
-                </a:solidFill>
-                <a:latin typeface="Calibri"/>
-              </a:rPr>
-              <a:t>Images couleur, 224×224 (VGG16)</a:t>
-            </a:r>
-          </a:p>
-          <a:p>
-            <a:pPr>
-              <a:spcAft>
-                <a:spcPts val="1400"/>
-              </a:spcAft>
-            </a:pPr>
-            <a:r>
-              <a:rPr sz="1800" b="1">
-                <a:solidFill>
-                  <a:srgbClr val="3F8A5B"/>
-                </a:solidFill>
-                <a:latin typeface="Calibri"/>
-              </a:rPr>
-              <a:t>›  </a:t>
-            </a:r>
-            <a:r>
-              <a:rPr sz="1800">
-                <a:solidFill>
-                  <a:srgbClr val="3C3C3C"/>
-                </a:solidFill>
-                <a:latin typeface="Calibri"/>
-              </a:rPr>
-              <a:t>Code écrit, pas lancé (pas de GPU
-assez puissant dans le temps imparti)</a:t>
+              <a:t>On ajoute une petite tête entraînée
+sur nos 6 races (images couleur 224×224)</a:t>
             </a:r>
           </a:p>
         </p:txBody>
@@ -5952,8 +5901,8 @@
         </p:nvSpPr>
         <p:spPr>
           <a:xfrm>
-            <a:off x="7498079" y="2103120"/>
-            <a:ext cx="4114800" cy="2468880"/>
+            <a:off x="548640" y="4572000"/>
+            <a:ext cx="5486400" cy="1371600"/>
           </a:xfrm>
           <a:prstGeom prst="rect">
             <a:avLst/>
@@ -5996,8 +5945,8 @@
         </p:nvSpPr>
         <p:spPr>
           <a:xfrm>
-            <a:off x="7772400" y="2468880"/>
-            <a:ext cx="3566160" cy="1828800"/>
+            <a:off x="640080" y="4736592"/>
+            <a:ext cx="5303520" cy="457200"/>
           </a:xfrm>
           <a:prstGeom prst="rect">
             <a:avLst/>
@@ -6010,15 +5959,15 @@
           </a:bodyPr>
           <a:lstStyle/>
           <a:p>
-            <a:pPr algn="l"/>
-            <a:r>
-              <a:rPr sz="1800" b="1" i="0">
+            <a:pPr algn="ctr"/>
+            <a:r>
+              <a:rPr sz="1600" b="1" i="0">
                 <a:solidFill>
                   <a:srgbClr val="E37B28"/>
                 </a:solidFill>
                 <a:latin typeface="Calibri"/>
               </a:rPr>
-              <a:t>Gain attendu</a:t>
+              <a:t>PCA+HOG  →  VGG16</a:t>
             </a:r>
           </a:p>
         </p:txBody>
@@ -6031,8 +5980,8 @@
         </p:nvSpPr>
         <p:spPr>
           <a:xfrm>
-            <a:off x="7772400" y="3017520"/>
-            <a:ext cx="3566160" cy="1463040"/>
+            <a:off x="640080" y="5120640"/>
+            <a:ext cx="5303520" cy="731520"/>
           </a:xfrm>
           <a:prstGeom prst="rect">
             <a:avLst/>
@@ -6045,43 +5994,43 @@
           </a:bodyPr>
           <a:lstStyle/>
           <a:p>
-            <a:pPr algn="l"/>
-            <a:r>
-              <a:rPr sz="2000" b="0" i="0">
+            <a:pPr algn="ctr"/>
+            <a:r>
+              <a:rPr sz="3000" b="1" i="0">
                 <a:solidFill>
                   <a:srgbClr val="FFFFFF"/>
                 </a:solidFill>
                 <a:latin typeface="Calibri"/>
               </a:rPr>
-              <a:t>+ plusieurs dizaines</a:t>
-            </a:r>
-          </a:p>
-          <a:p>
-            <a:pPr algn="l"/>
-            <a:r>
-              <a:rPr sz="2000" b="0" i="0">
-                <a:solidFill>
-                  <a:srgbClr val="FFFFFF"/>
-                </a:solidFill>
-                <a:latin typeface="Calibri"/>
-              </a:rPr>
-              <a:t>de points</a:t>
-            </a:r>
-          </a:p>
-          <a:p>
-            <a:pPr algn="l"/>
-            <a:r>
-              <a:rPr sz="2000" b="0" i="0">
-                <a:solidFill>
-                  <a:srgbClr val="FFFFFF"/>
-                </a:solidFill>
-                <a:latin typeface="Calibri"/>
-              </a:rPr>
-              <a:t>vs méthodes classiques</a:t>
-            </a:r>
-          </a:p>
-        </p:txBody>
-      </p:sp>
+              <a:t>57 %   →   98 %</a:t>
+            </a:r>
+          </a:p>
+        </p:txBody>
+      </p:sp>
+      <p:pic>
+        <p:nvPicPr>
+          <p:cNvPr id="12" name="Picture 11" descr="confusion_matrix_vgg16.png"/>
+          <p:cNvPicPr>
+            <a:picLocks noChangeAspect="1"/>
+          </p:cNvPicPr>
+          <p:nvPr/>
+        </p:nvPicPr>
+        <p:blipFill>
+          <a:blip r:embed="rId2"/>
+          <a:stretch>
+            <a:fillRect/>
+          </a:stretch>
+        </p:blipFill>
+        <p:spPr>
+          <a:xfrm>
+            <a:off x="6309360" y="1401583"/>
+            <a:ext cx="5486400" cy="4786354"/>
+          </a:xfrm>
+          <a:prstGeom prst="rect">
+            <a:avLst/>
+          </a:prstGeom>
+        </p:spPr>
+      </p:pic>
     </p:spTree>
   </p:cSld>
   <p:clrMapOvr>
@@ -6316,7 +6265,7 @@
                 </a:solidFill>
                 <a:latin typeface="Calibri"/>
               </a:rPr>
-              <a:t>La qualité des caractéristiques fixe la limite : ici ~57 %</a:t>
+              <a:t>La qualité des caractéristiques fixe la limite : ~57 % en classique</a:t>
             </a:r>
           </a:p>
           <a:p>
@@ -6341,7 +6290,7 @@
                 </a:solidFill>
                 <a:latin typeface="Calibri"/>
               </a:rPr>
-              <a:t>Transfer learning = suite logique pour dépasser ce plafond</a:t>
+              <a:t>Transfer learning (VGG16) confirme le diagnostic : 98 %</a:t>
             </a:r>
           </a:p>
         </p:txBody>

</xml_diff>

<commit_message>
Mise a jour complete du rapport, des slides, du script oral et des scripts de code
</commit_message>
<xml_diff>
--- a/presentation/presentation.pptx
+++ b/presentation/presentation.pptx
@@ -3613,8 +3613,8 @@
         </p:blipFill>
         <p:spPr>
           <a:xfrm>
-            <a:off x="984846" y="1554480"/>
-            <a:ext cx="5345507" cy="4663440"/>
+            <a:off x="982592" y="1554480"/>
+            <a:ext cx="5350016" cy="4663440"/>
           </a:xfrm>
           <a:prstGeom prst="rect">
             <a:avLst/>
@@ -4100,7 +4100,7 @@
                 <a:latin typeface="Calibri"/>
               </a:rPr>
               <a:t>GridSearchCV (CV 3 folds) :
-C=5, γ=1e-4, 15 axes PCA/race</a:t>
+C=10, γ=0,005, 5 axes PCA/classe</a:t>
             </a:r>
           </a:p>
           <a:p>
@@ -4319,7 +4319,7 @@
                 </a:solidFill>
                 <a:latin typeface="Calibri"/>
               </a:rPr>
-              <a:t>OvO — linéaire</a:t>
+              <a:t>OvO — noyau linéaire</a:t>
             </a:r>
           </a:p>
         </p:txBody>
@@ -4354,7 +4354,7 @@
                 </a:solidFill>
                 <a:latin typeface="Calibri"/>
               </a:rPr>
-              <a:t>53,78 %</a:t>
+              <a:t>52,59 %</a:t>
             </a:r>
           </a:p>
         </p:txBody>
@@ -4433,7 +4433,7 @@
                 </a:solidFill>
                 <a:latin typeface="Calibri"/>
               </a:rPr>
-              <a:t>OvR — linéaire</a:t>
+              <a:t>OvR — noyau linéaire</a:t>
             </a:r>
           </a:p>
         </p:txBody>
@@ -4468,7 +4468,7 @@
                 </a:solidFill>
                 <a:latin typeface="Calibri"/>
               </a:rPr>
-              <a:t>50,60 %</a:t>
+              <a:t>48,61 %</a:t>
             </a:r>
           </a:p>
         </p:txBody>
@@ -4547,7 +4547,7 @@
                 </a:solidFill>
                 <a:latin typeface="Calibri"/>
               </a:rPr>
-              <a:t>OvO — RBF réglé</a:t>
+              <a:t>OvO — noyau RBF réglé</a:t>
             </a:r>
           </a:p>
         </p:txBody>
@@ -4582,7 +4582,7 @@
                 </a:solidFill>
                 <a:latin typeface="Calibri"/>
               </a:rPr>
-              <a:t>55,78 %</a:t>
+              <a:t>58,57 %</a:t>
             </a:r>
           </a:p>
         </p:txBody>
@@ -4661,7 +4661,7 @@
                 </a:solidFill>
                 <a:latin typeface="Calibri"/>
               </a:rPr>
-              <a:t>OvR — RBF réglé</a:t>
+              <a:t>OvR — noyau RBF réglé</a:t>
             </a:r>
           </a:p>
         </p:txBody>
@@ -4696,7 +4696,7 @@
                 </a:solidFill>
                 <a:latin typeface="Calibri"/>
               </a:rPr>
-              <a:t>57,77 %</a:t>
+              <a:t>59,36 %</a:t>
             </a:r>
           </a:p>
         </p:txBody>
@@ -4972,8 +4972,8 @@
         </p:blipFill>
         <p:spPr>
           <a:xfrm>
-            <a:off x="2058832" y="1463040"/>
-            <a:ext cx="5392095" cy="4846320"/>
+            <a:off x="2059294" y="1463040"/>
+            <a:ext cx="5391172" cy="4846320"/>
           </a:xfrm>
           <a:prstGeom prst="rect">
             <a:avLst/>
@@ -5216,7 +5216,7 @@
                 </a:solidFill>
                 <a:latin typeface="Calibri"/>
               </a:rPr>
-              <a:t>Pourquoi on plafonne vers 55-58 %</a:t>
+              <a:t>Pourquoi on plafonne sous les 60 %</a:t>
             </a:r>
           </a:p>
         </p:txBody>
@@ -6002,7 +6002,7 @@
                 </a:solidFill>
                 <a:latin typeface="Calibri"/>
               </a:rPr>
-              <a:t>57 %   →   98 %</a:t>
+              <a:t>59 %   →   98 %</a:t>
             </a:r>
           </a:p>
         </p:txBody>
@@ -6265,7 +6265,7 @@
                 </a:solidFill>
                 <a:latin typeface="Calibri"/>
               </a:rPr>
-              <a:t>La qualité des caractéristiques fixe la limite : ~57 % en classique</a:t>
+              <a:t>La qualité des caractéristiques fixe la limite : ~59 % en classique</a:t>
             </a:r>
           </a:p>
           <a:p>
@@ -6573,7 +6573,7 @@
                 </a:solidFill>
                 <a:latin typeface="Calibri"/>
               </a:rPr>
-              <a:t>de données (PASCAL VOC).</a:t>
+              <a:t>de données (Stanford Dogs).</a:t>
             </a:r>
           </a:p>
         </p:txBody>
@@ -7446,7 +7446,7 @@
                 </a:solidFill>
                 <a:latin typeface="Calibri"/>
               </a:rPr>
-              <a:t>Jeu SmallDB tiré de PASCAL VOC</a:t>
+              <a:t>Jeu SmallDB tiré de Stanford Dogs</a:t>
             </a:r>
           </a:p>
           <a:p>
@@ -8229,8 +8229,8 @@
         </p:blipFill>
         <p:spPr>
           <a:xfrm>
-            <a:off x="1966669" y="1463040"/>
-            <a:ext cx="4753461" cy="4846320"/>
+            <a:off x="1997622" y="1463040"/>
+            <a:ext cx="4691556" cy="4846320"/>
           </a:xfrm>
           <a:prstGeom prst="rect">
             <a:avLst/>
@@ -8280,7 +8280,7 @@
                 </a:solidFill>
                 <a:latin typeface="Calibri"/>
               </a:rPr>
-              <a:t>Cible : 256×256 px</a:t>
+              <a:t>Cible : 64×64 px</a:t>
             </a:r>
           </a:p>
           <a:p>
@@ -8331,8 +8331,8 @@
                 </a:solidFill>
                 <a:latin typeface="Calibri"/>
               </a:rPr>
-              <a:t>Bords vides à remplir :
-noir / blanc / continu</a:t>
+              <a:t>Bords vides à remplir : noir, blanc,
+continu, miroir, floutage</a:t>
             </a:r>
           </a:p>
           <a:p>
@@ -8357,9 +8357,8 @@
                 </a:solidFill>
                 <a:latin typeface="Calibri"/>
               </a:rPr>
-              <a:t>On garde le remplissage
-continu : pas de faux
-contour pour le HOG</a:t>
+              <a:t>Choix : propagation de flou
+pour éviter de faux contours HOG</a:t>
             </a:r>
           </a:p>
         </p:txBody>
@@ -8635,8 +8634,8 @@
         </p:blipFill>
         <p:spPr>
           <a:xfrm>
-            <a:off x="548640" y="2314406"/>
-            <a:ext cx="6400800" cy="3143588"/>
+            <a:off x="548640" y="2310369"/>
+            <a:ext cx="6400800" cy="3151662"/>
           </a:xfrm>
           <a:prstGeom prst="rect">
             <a:avLst/>
@@ -8710,7 +8709,7 @@
                 </a:solidFill>
                 <a:latin typeface="Calibri"/>
               </a:rPr>
-              <a:t>256×256 = 65 536 valeurs → trop</a:t>
+              <a:t>64×64 = 4 096 valeurs → trop</a:t>
             </a:r>
           </a:p>
           <a:p>
@@ -9036,8 +9035,8 @@
         </p:blipFill>
         <p:spPr>
           <a:xfrm>
-            <a:off x="856900" y="1463040"/>
-            <a:ext cx="6150040" cy="4846320"/>
+            <a:off x="860386" y="1463040"/>
+            <a:ext cx="6143067" cy="4846320"/>
           </a:xfrm>
           <a:prstGeom prst="rect">
             <a:avLst/>
@@ -9893,8 +9892,8 @@
         </p:blipFill>
         <p:spPr>
           <a:xfrm>
-            <a:off x="457200" y="2057912"/>
-            <a:ext cx="11247120" cy="2925056"/>
+            <a:off x="457200" y="2054738"/>
+            <a:ext cx="11247120" cy="2931403"/>
           </a:xfrm>
           <a:prstGeom prst="rect">
             <a:avLst/>

</xml_diff>